<commit_message>
Grade 4 deck: simplify answers
Co-Authored-By: Claude Opus 5.5 <noreply@anthropic.com>
Claude-Session: https://claude.ai/code/session_01KP6dYn8bqeiPZU9EGavBNs
</commit_message>
<xml_diff>
--- a/الصف-الرابع/رحلة-المستكشفة-السلسلة-والشبكة-الغذائية.pptx
+++ b/الصف-الرابع/رحلة-المستكشفة-السلسلة-والشبكة-الغذائية.pptx
@@ -8297,7 +8297,7 @@
                 <a:ea typeface="Tahoma" pitchFamily="34" charset="-122"/>
                 <a:cs typeface="Tahoma" pitchFamily="34" charset="-120"/>
               </a:rPr>
-              <a:t>لا تجد غذاءً، فلا تصل إليها الطاقة.</a:t>
+              <a:t>لا تجد غذاءً.</a:t>
             </a:r>
             <a:endParaRPr lang="ar-SA" sz="1500" dirty="0"/>
           </a:p>
@@ -9327,7 +9327,7 @@
                 <a:ea typeface="Tahoma" pitchFamily="34" charset="-122"/>
                 <a:cs typeface="Tahoma" pitchFamily="34" charset="-120"/>
               </a:rPr>
-              <a:t>مفترس لليرقة، وفريسة للسحلية.</a:t>
+              <a:t>الاثنين: يصطاد اليرقة، وتصطاده السحلية.</a:t>
             </a:r>
             <a:endParaRPr lang="ar-SA" sz="1500" dirty="0"/>
           </a:p>
@@ -10381,7 +10381,7 @@
                 <a:ea typeface="Tahoma" pitchFamily="34" charset="-122"/>
                 <a:cs typeface="Tahoma" pitchFamily="34" charset="-120"/>
               </a:rPr>
-              <a:t>صغُرت؛ لأن كل مخلوق يستخدم معظم الطاقة التي يحصل عليها.</a:t>
+              <a:t>صغُرت؛ الطاقة تقلّ في كل حلقة.</a:t>
             </a:r>
             <a:endParaRPr lang="ar-SA" sz="1500" dirty="0"/>
           </a:p>
@@ -11459,7 +11459,7 @@
                 <a:ea typeface="Tahoma" pitchFamily="34" charset="-122"/>
                 <a:cs typeface="Tahoma" pitchFamily="34" charset="-120"/>
               </a:rPr>
-              <a:t>لا؛ وصلتها الطاقة عبر السلسلة كلها من الشمس.</a:t>
+              <a:t>لا؛ من السحلية التي أكلتها.</a:t>
             </a:r>
             <a:endParaRPr lang="ar-SA" sz="1500" dirty="0"/>
           </a:p>
@@ -13626,7 +13626,7 @@
                 <a:ea typeface="Tahoma" pitchFamily="34" charset="-122"/>
                 <a:cs typeface="Tahoma" pitchFamily="34" charset="-120"/>
               </a:rPr>
-              <a:t>✔ نبات الشوك؛ لأنه يصنع غذاءه بنفسه مستخدمًا طاقة الشمس.</a:t>
+              <a:t>✔ نبات الشوك؛ يصنع غذاءه بنفسه.</a:t>
             </a:r>
             <a:endParaRPr lang="ar-SA" sz="1550" dirty="0"/>
           </a:p>
@@ -14552,7 +14552,7 @@
                 <a:ea typeface="Tahoma" pitchFamily="34" charset="-122"/>
                 <a:cs typeface="Tahoma" pitchFamily="34" charset="-120"/>
               </a:rPr>
-              <a:t>السهم يشير إلى المستهلك التالي؛ أي اتجاه انتقال الطاقة من الغذاء إلى آكله.</a:t>
+              <a:t>السهم يشير إلى من يأكل؛ أي اتجاه انتقال الطاقة.</a:t>
             </a:r>
             <a:endParaRPr lang="ar-SA" sz="1500" dirty="0"/>
           </a:p>
@@ -14726,7 +14726,7 @@
                 <a:ea typeface="Tahoma" pitchFamily="34" charset="-122"/>
                 <a:cs typeface="Tahoma" pitchFamily="34" charset="-120"/>
               </a:rPr>
-              <a:t>تبدأ بمنتِج يصنع غذاءه بطاقة الشمس، مثل نبات الشوك.</a:t>
+              <a:t>تبدأ بمنتِج مثل نبات الشوك.</a:t>
             </a:r>
             <a:endParaRPr lang="ar-SA" sz="1500" dirty="0"/>
           </a:p>
@@ -14900,7 +14900,7 @@
                 <a:ea typeface="Tahoma" pitchFamily="34" charset="-122"/>
                 <a:cs typeface="Tahoma" pitchFamily="34" charset="-120"/>
               </a:rPr>
-              <a:t>لا يستطيع؛ تحصل البومة على الطاقة من السحلية التي تأكلها.</a:t>
+              <a:t>البومة تأخذ طاقتها من السحلية التي تأكلها.</a:t>
             </a:r>
             <a:endParaRPr lang="ar-SA" sz="1500" dirty="0"/>
           </a:p>
@@ -17048,7 +17048,7 @@
                 <a:ea typeface="Tahoma" pitchFamily="34" charset="-122"/>
                 <a:cs typeface="Tahoma" pitchFamily="34" charset="-120"/>
               </a:rPr>
-              <a:t>نعم، تتشابهان؛ فالسلسلة في البركة تبدأ أيضًا بمخلوقات تلتقط طاقة الشمس، مثل الطحالب 🌿</a:t>
+              <a:t>نعم؛ تبدأ أيضًا بمنتِج يأخذ طاقة الشمس: الطحالب 🌿</a:t>
             </a:r>
             <a:endParaRPr lang="ar-SA" sz="1650" dirty="0"/>
           </a:p>
@@ -18171,7 +18171,7 @@
                 <a:ea typeface="Tahoma" pitchFamily="34" charset="-122"/>
                 <a:cs typeface="Tahoma" pitchFamily="34" charset="-120"/>
               </a:rPr>
-              <a:t>بالطحالب والنباتات الخضراء التي تلتقط طاقة الشمس.</a:t>
+              <a:t>بالطحالب والنباتات الخضراء.</a:t>
             </a:r>
             <a:endParaRPr lang="ar-SA" sz="1400" dirty="0"/>
           </a:p>
@@ -18328,7 +18328,7 @@
                 <a:ea typeface="Tahoma" pitchFamily="34" charset="-122"/>
                 <a:cs typeface="Tahoma" pitchFamily="34" charset="-120"/>
               </a:rPr>
-              <a:t>في الخلايا، على شكل سكر.</a:t>
+              <a:t>في خلاياها، على شكل سكر.</a:t>
             </a:r>
             <a:endParaRPr lang="ar-SA" sz="1400" dirty="0"/>
           </a:p>
@@ -18485,7 +18485,7 @@
                 <a:ea typeface="Tahoma" pitchFamily="34" charset="-122"/>
                 <a:cs typeface="Tahoma" pitchFamily="34" charset="-120"/>
               </a:rPr>
-              <a:t>لإطلاق الطاقة المخزونة في الطحالب؛ للقيام بوظائف الحياة كالحركة.</a:t>
+              <a:t>لتُخرج الطاقة من الطحالب وتتحرك.</a:t>
             </a:r>
             <a:endParaRPr lang="ar-SA" sz="1400" dirty="0"/>
           </a:p>
@@ -18642,7 +18642,7 @@
                 <a:ea typeface="Tahoma" pitchFamily="34" charset="-122"/>
                 <a:cs typeface="Tahoma" pitchFamily="34" charset="-120"/>
               </a:rPr>
-              <a:t>مالك الحزين؛ أخذ طاقته من سمكة الشمس التي اصطادها.</a:t>
+              <a:t>مالك الحزين؛ من سمكة الشمس.</a:t>
             </a:r>
             <a:endParaRPr lang="ar-SA" sz="1400" dirty="0"/>
           </a:p>
@@ -23712,7 +23712,7 @@
                 <a:ea typeface="Tahoma" pitchFamily="34" charset="-122"/>
                 <a:cs typeface="Tahoma" pitchFamily="34" charset="-120"/>
               </a:rPr>
-              <a:t>بالطحالب والنباتات الخضراء.</a:t>
+              <a:t>بالطحالب.</a:t>
             </a:r>
             <a:r>
               <a:rPr lang="ar-SA" altLang="en-US" sz="1450" b="1" dirty="0">
@@ -23942,7 +23942,7 @@
                 <a:ea typeface="Tahoma" pitchFamily="34" charset="-122"/>
                 <a:cs typeface="Tahoma" pitchFamily="34" charset="-120"/>
               </a:rPr>
-              <a:t>لإطلاق الطاقة المخزونة في الطحالب التي أكلتها؛ لتقوم بوظائف الحياة كالحركة.</a:t>
+              <a:t>لتُخرج الطاقة من الطحالب وتتحرك.</a:t>
             </a:r>
             <a:r>
               <a:rPr lang="ar-SA" altLang="en-US" sz="1450" b="1" dirty="0">
@@ -24172,7 +24172,7 @@
                 <a:ea typeface="Tahoma" pitchFamily="34" charset="-122"/>
                 <a:cs typeface="Tahoma" pitchFamily="34" charset="-120"/>
               </a:rPr>
-              <a:t>يقلّ الذباب المائي ثم سمك الشمس، فلا يجد مالك الحزين غذاءً كافيًا؛ لأن كل حلقة تعتمد على ما قبلها.</a:t>
+              <a:t>لا يجد مالك الحزين غذاءً كافيًا.</a:t>
             </a:r>
             <a:r>
               <a:rPr lang="ar-SA" altLang="en-US" sz="1450" b="1" dirty="0">
@@ -24914,7 +24914,7 @@
                 <a:ea typeface="Tahoma" pitchFamily="34" charset="-122"/>
                 <a:cs typeface="Tahoma" pitchFamily="34" charset="-120"/>
               </a:rPr>
-              <a:t>لأن المخلوقات الحية ترتبط بعضها ببعض كحلقات السلسلة؛ فكل حلقة تحصل على الطاقة من الحلقة التي قبلها، وإذا انقطعت حلقة تأثرت الحلقات التي بعدها.</a:t>
+              <a:t>لأن المخلوقات مرتبطة مثل حلقات السلسلة؛ كل حلقة تأخذ طاقتها من التي قبلها.</a:t>
             </a:r>
             <a:endParaRPr lang="ar-SA" sz="1550" dirty="0"/>
           </a:p>
@@ -25803,7 +25803,7 @@
                 <a:ea typeface="Tahoma" pitchFamily="34" charset="-122"/>
                 <a:cs typeface="Tahoma" pitchFamily="34" charset="-120"/>
               </a:rPr>
-              <a:t>لا تكفي سلسلة واحدة؛ نحتاج إلى نموذج يجمع عدة سلاسل متداخلة… إنها </a:t>
+              <a:t>لا تكفي؛ نحتاج عدة سلاسل متداخلة… إنها </a:t>
             </a:r>
             <a:r>
               <a:rPr lang="ar-SA" altLang="en-US" sz="1700" b="1" dirty="0">
@@ -26528,7 +26528,7 @@
                 <a:ea typeface="Tahoma" pitchFamily="34" charset="-122"/>
                 <a:cs typeface="Tahoma" pitchFamily="34" charset="-120"/>
               </a:rPr>
-              <a:t>لأنها تبيّن مسارًا واحدًا لنقل الطاقة، ومعظم الأنظمة البيئية لها سلاسل متداخلة.</a:t>
+              <a:t>لأنها تبيّن طريقًا واحدًا للطاقة فقط.</a:t>
             </a:r>
             <a:endParaRPr lang="ar-SA" sz="1400" dirty="0"/>
           </a:p>
@@ -26685,7 +26685,7 @@
                 <a:ea typeface="Tahoma" pitchFamily="34" charset="-122"/>
                 <a:cs typeface="Tahoma" pitchFamily="34" charset="-120"/>
               </a:rPr>
-              <a:t>الشبكة الغذائية: سلاسل غذائية متداخلة توضّح ترابط سلاسل الغذاء في النظام البيئي.</a:t>
+              <a:t>الشبكة الغذائية: سلاسل غذائية متداخلة.</a:t>
             </a:r>
             <a:endParaRPr lang="ar-SA" sz="1400" dirty="0"/>
           </a:p>
@@ -26842,7 +26842,7 @@
                 <a:ea typeface="Tahoma" pitchFamily="34" charset="-122"/>
                 <a:cs typeface="Tahoma" pitchFamily="34" charset="-120"/>
               </a:rPr>
-              <a:t>المفترس آكل اللحوم الذي يصطاد ليحصل على طعامه، والفريسة المخلوق الذي تم اصطياده.</a:t>
+              <a:t>المفترس يصطاد، والفريسة تُصطاد.</a:t>
             </a:r>
             <a:endParaRPr lang="ar-SA" sz="1400" dirty="0"/>
           </a:p>
@@ -26999,7 +26999,7 @@
                 <a:ea typeface="Tahoma" pitchFamily="34" charset="-122"/>
                 <a:cs typeface="Tahoma" pitchFamily="34" charset="-120"/>
               </a:rPr>
-              <a:t>الحوت القاتل؛ تتجه إليه ثلاثة أسهم (التونة، والدلفين، والنورس).</a:t>
+              <a:t>الحوت القاتل؛ تصل إليه ٣ أسهم.</a:t>
             </a:r>
             <a:endParaRPr lang="ar-SA" sz="1400" dirty="0"/>
           </a:p>
@@ -31378,7 +31378,7 @@
                 <a:ea typeface="Tahoma" pitchFamily="34" charset="-122"/>
                 <a:cs typeface="Tahoma" pitchFamily="34" charset="-120"/>
               </a:rPr>
-              <a:t>مخلوقات حيّة تحلّل المواد الميتة لتحصل على الطاقة، وتعيد المواد إلى النظام البيئي موادَّ مغذية.</a:t>
+              <a:t>مخلوقات تحلّل المواد الميتة وتعيدها غذاءً للتربة.</a:t>
             </a:r>
             <a:endParaRPr lang="ar-SA" sz="1500" dirty="0"/>
           </a:p>
@@ -31511,7 +31511,7 @@
                 <a:ea typeface="Tahoma" pitchFamily="34" charset="-122"/>
                 <a:cs typeface="Tahoma" pitchFamily="34" charset="-120"/>
               </a:rPr>
-              <a:t>الديدان، والبكتيريا، والفطريات.</a:t>
+              <a:t>الديدان، البكتيريا، الفطريات.</a:t>
             </a:r>
             <a:endParaRPr lang="ar-SA" sz="1500" dirty="0"/>
           </a:p>
@@ -31644,7 +31644,7 @@
                 <a:ea typeface="Tahoma" pitchFamily="34" charset="-122"/>
                 <a:cs typeface="Tahoma" pitchFamily="34" charset="-120"/>
               </a:rPr>
-              <a:t>تتراكم بقايا المخلوقات الميتة، ولا تعود المواد المغذية إلى التربة.</a:t>
+              <a:t>تتراكم المخلوقات الميتة، ولا تتغذى التربة.</a:t>
             </a:r>
             <a:endParaRPr lang="ar-SA" sz="1500" dirty="0"/>
           </a:p>
@@ -35212,7 +35212,7 @@
                 <a:ea typeface="Tahoma" pitchFamily="34" charset="-122"/>
                 <a:cs typeface="Tahoma" pitchFamily="34" charset="-120"/>
               </a:rPr>
-              <a:t>التونة والدلفين وطائر النورس؛ لأنها تتغذى عليها، ثم يتأثر الحوت القاتل. وقد تزداد العوالق لقلّة من يأكلها.</a:t>
+              <a:t>التونة والدلفين والنورس؛ لأنها تأكل السردين.</a:t>
             </a:r>
             <a:endParaRPr lang="ar-SA" sz="1450" dirty="0"/>
           </a:p>
@@ -35364,7 +35364,7 @@
                 <a:ea typeface="Tahoma" pitchFamily="34" charset="-122"/>
                 <a:cs typeface="Tahoma" pitchFamily="34" charset="-120"/>
               </a:rPr>
-              <a:t>السلسلة المنفردة؛ لأن لها مسارًا واحدًا، أما في الشبكة فقد يجد المفترس غذاءً بديلًا.</a:t>
+              <a:t>السلسلة؛ لأن الشبكة فيها غذاء بديل.</a:t>
             </a:r>
             <a:endParaRPr lang="ar-SA" sz="1450" dirty="0"/>
           </a:p>
@@ -35516,7 +35516,7 @@
                 <a:ea typeface="Tahoma" pitchFamily="34" charset="-122"/>
                 <a:cs typeface="Tahoma" pitchFamily="34" charset="-120"/>
               </a:rPr>
-              <a:t>مثال: العشب ← الجرادة ← الضب ← الثعبان ← الصقر، والعشب ← الضب، والضب ← الصقر.</a:t>
+              <a:t>مثال: العشب ← الجرادة ← الضب ← الصقر، والضب ← الثعبان ← الصقر.</a:t>
             </a:r>
             <a:endParaRPr lang="ar-SA" sz="1450" dirty="0"/>
           </a:p>
@@ -36947,7 +36947,7 @@
                 <a:ea typeface="Tahoma" pitchFamily="34" charset="-122"/>
                 <a:cs typeface="Tahoma" pitchFamily="34" charset="-120"/>
               </a:rPr>
-              <a:t>✔ لأن اختفاء مخلوق من الشبكة الغذائية يؤثر في بقية المخلوقات.</a:t>
+              <a:t>✔ لأن اختفاء مخلوق يضرّ الشبكة كلها.</a:t>
             </a:r>
             <a:endParaRPr lang="ar-SA" sz="1600" dirty="0"/>
           </a:p>
@@ -37534,7 +37534,7 @@
                 <a:ea typeface="Tahoma" pitchFamily="34" charset="-122"/>
                 <a:cs typeface="Tahoma" pitchFamily="34" charset="-120"/>
               </a:rPr>
-              <a:t>✔ ٥ حلقات، و٤ أسهم (عدد الأسهم = عدد الحلقات − ١).</a:t>
+              <a:t>✔ ٥ حلقات، و٤ أسهم.</a:t>
             </a:r>
             <a:endParaRPr lang="ar-SA" sz="1500" dirty="0"/>
           </a:p>
@@ -37640,7 +37640,7 @@
                 <a:ea typeface="Tahoma" pitchFamily="34" charset="-122"/>
                 <a:cs typeface="Tahoma" pitchFamily="34" charset="-120"/>
               </a:rPr>
-              <a:t>✔ سلاسل غذائية متداخلة توضّح ترابط سلاسل الغذاء في النظام البيئي.</a:t>
+              <a:t>✔ سلاسل غذائية متداخلة.</a:t>
             </a:r>
             <a:endParaRPr lang="ar-SA" sz="1450" dirty="0"/>
           </a:p>
@@ -38651,7 +38651,7 @@
                 <a:ea typeface="Tahoma" pitchFamily="34" charset="-122"/>
                 <a:cs typeface="Tahoma" pitchFamily="34" charset="-120"/>
               </a:rPr>
-              <a:t>سمكة السردين (أو التونة، أو الدلفين، أو طائر النورس).</a:t>
+              <a:t>سمكة السردين.</a:t>
             </a:r>
             <a:endParaRPr lang="ar-SA" sz="1500" dirty="0"/>
           </a:p>
@@ -41266,7 +41266,7 @@
                 <a:ea typeface="Tahoma" pitchFamily="34" charset="-122"/>
                 <a:cs typeface="Tahoma" pitchFamily="34" charset="-120"/>
               </a:rPr>
-              <a:t>لأنها في آخر السلسلة؛ وكل مخلوق يستخدم معظم الطاقة التي يحصل عليها، فلا ينتقل إلى المخلوق التالي إلا جزء صغير (تذكّرن كيف صغُرت كرة الطاقة في جولة الواقع الافتراضي!).</a:t>
+              <a:t>لأنها آخر السلسلة، والطاقة تقلّ في كل حلقة (مثل كرة الطاقة ⚡).</a:t>
             </a:r>
             <a:endParaRPr lang="ar-SA" sz="1550" dirty="0"/>
           </a:p>
@@ -47968,7 +47968,7 @@
                 <a:ea typeface="Tahoma" pitchFamily="34" charset="-122"/>
                 <a:cs typeface="Tahoma" pitchFamily="34" charset="-120"/>
               </a:rPr>
-              <a:t>لا تأخذ البومة طاقتها من الشمس مباشرة، بل من غذائها… وغذاؤها حصل على الطاقة من مخلوق قبله! هيا نقرأ ونكتشف 📖</a:t>
+              <a:t>لا؛ البومة تأخذ طاقتها من غذائها. هيا نكتشف 📖</a:t>
             </a:r>
             <a:endParaRPr lang="ar-SA" sz="1650" dirty="0"/>
           </a:p>
@@ -48957,7 +48957,7 @@
                 <a:ea typeface="Tahoma" pitchFamily="34" charset="-122"/>
                 <a:cs typeface="Tahoma" pitchFamily="34" charset="-120"/>
               </a:rPr>
-              <a:t>الشمس.</a:t>
+              <a:t>الشمس ☀️</a:t>
             </a:r>
             <a:endParaRPr lang="ar-SA" sz="1400" dirty="0"/>
           </a:p>
@@ -49114,7 +49114,7 @@
                 <a:ea typeface="Tahoma" pitchFamily="34" charset="-122"/>
                 <a:cs typeface="Tahoma" pitchFamily="34" charset="-120"/>
               </a:rPr>
-              <a:t>لأن الطاقة تُختزَن في المنتجات، ثم تنتقل منها إلى المستهلكات عن طريق الغذاء.</a:t>
+              <a:t>لأنه يأخذ الطاقة من الغذاء الذي يأكله.</a:t>
             </a:r>
             <a:endParaRPr lang="ar-SA" sz="1400" dirty="0"/>
           </a:p>
@@ -49271,7 +49271,7 @@
                 <a:ea typeface="Tahoma" pitchFamily="34" charset="-122"/>
                 <a:cs typeface="Tahoma" pitchFamily="34" charset="-120"/>
               </a:rPr>
-              <a:t>السلسلة الغذائية: انتقال الطاقة من مخلوق حي إلى آخر عن طريق الغذاء.</a:t>
+              <a:t>السلسلة الغذائية: انتقال الطاقة من مخلوق إلى آخر بالغذاء.</a:t>
             </a:r>
             <a:endParaRPr lang="ar-SA" sz="1400" dirty="0"/>
           </a:p>
@@ -49428,7 +49428,7 @@
                 <a:ea typeface="Tahoma" pitchFamily="34" charset="-122"/>
                 <a:cs typeface="Tahoma" pitchFamily="34" charset="-120"/>
               </a:rPr>
-              <a:t>من نبات الشوك (منتِج) إلى اليرقة ثم السرعوف ثم السحلية ثم البومة.</a:t>
+              <a:t>نبات الشوك ← اليرقة ← السرعوف ← السحلية ← البومة</a:t>
             </a:r>
             <a:endParaRPr lang="ar-SA" sz="1400" dirty="0"/>
           </a:p>

</xml_diff>